<commit_message>
fix(governance-v3): final presentation polish
- Use calculated AGLIPAY compliance (21%) in Slide 1 executive observation
- Enforce 12pt minimum font across all slides
- Shorten matrix status cells to ✓ / — to prevent wrapping/clipping
- Consolidate multi-paragraph shape text to avoid duplicated executive notes
- Adjust Slide 3 table row/frame heights to avoid slide overflow
- Ensure build script refreshes dist/templates from source
</commit_message>
<xml_diff>
--- a/src/modules/governance-v3/templates/Onboarding Status.pptx
+++ b/src/modules/governance-v3/templates/Onboarding Status.pptx
@@ -11419,9 +11419,7 @@
           <a:noFill/>
         </p:spPr>
         <p:txBody>
-          <a:bodyPr wrap="none" lIns="0" tIns="0" rIns="0" bIns="0" anchor="ctr">
-            <a:spAutoFit/>
-          </a:bodyPr>
+          <a:bodyPr wrap="none" lIns="0" tIns="0" rIns="0" bIns="0" anchor="ctr"/>
           <a:lstStyle/>
           <a:p>
             <a:pPr algn="l">
@@ -11473,13 +11471,11 @@
           <a:noFill/>
         </p:spPr>
         <p:txBody>
-          <a:bodyPr wrap="none" lIns="0" tIns="0" rIns="0" bIns="0" anchor="ctr">
-            <a:spAutoFit/>
-          </a:bodyPr>
+          <a:bodyPr wrap="none" lIns="0" tIns="0" rIns="0" bIns="0" anchor="ctr"/>
           <a:lstStyle/>
           <a:p>
             <a:pPr algn="l">
-              <a:defRPr sz="975" b="0">
+              <a:defRPr sz="1200" b="0">
                 <a:solidFill>
                   <a:srgbClr val="66758A"/>
                 </a:solidFill>
@@ -11489,7 +11485,7 @@
               </a:defRPr>
             </a:pPr>
             <a:r>
-              <a:rPr sz="975" b="0">
+              <a:rPr sz="1200" b="0">
                 <a:solidFill>
                   <a:srgbClr val="66758A"/>
                 </a:solidFill>
@@ -11519,7 +11515,7 @@
         <p:spPr>
           <a:xfrm>
             <a:off x="548640" y="6446520"/>
-            <a:ext cx="6400800" cy="164592"/>
+            <a:ext cx="6400800" cy="256032"/>
           </a:xfrm>
           <a:prstGeom prst="rect">
             <a:avLst/>
@@ -11527,14 +11523,12 @@
           <a:noFill/>
         </p:spPr>
         <p:txBody>
-          <a:bodyPr wrap="none" lIns="0" tIns="0" rIns="0" bIns="0">
-            <a:spAutoFit/>
-          </a:bodyPr>
+          <a:bodyPr wrap="none" lIns="0" tIns="0" rIns="0" bIns="0"/>
           <a:lstStyle/>
           <a:p>
             <a:pPr algn="l">
               <a:buNone/>
-              <a:defRPr sz="650">
+              <a:defRPr sz="1200">
                 <a:solidFill>
                   <a:srgbClr val="475569"/>
                 </a:solidFill>
@@ -11597,7 +11591,7 @@
           <a:p>
             <a:pPr algn="l">
               <a:buNone/>
-              <a:defRPr sz="750" b="0">
+              <a:defRPr sz="1200" b="0">
                 <a:solidFill>
                   <a:srgbClr val="66758A"/>
                 </a:solidFill>
@@ -11607,7 +11601,7 @@
               </a:defRPr>
             </a:pPr>
             <a:r>
-              <a:rPr sz="750" b="0" dirty="0">
+              <a:rPr sz="1200" b="0" dirty="0">
                 <a:solidFill>
                   <a:srgbClr val="66758A"/>
                 </a:solidFill>
@@ -11618,7 +11612,7 @@
               <a:t>✓ </a:t>
             </a:r>
             <a:r>
-              <a:rPr lang="en-US" sz="750" dirty="0">
+              <a:rPr lang="en-US" sz="1200" dirty="0">
                 <a:solidFill>
                   <a:srgbClr val="66758A"/>
                 </a:solidFill>
@@ -11629,7 +11623,7 @@
               <a:t>Submitted</a:t>
             </a:r>
             <a:r>
-              <a:rPr sz="750" b="0" dirty="0">
+              <a:rPr sz="1200" b="0" dirty="0">
                 <a:solidFill>
                   <a:srgbClr val="66758A"/>
                 </a:solidFill>
@@ -11637,7 +11631,7 @@
                 <a:ea typeface="Calibri"/>
                 <a:cs typeface="Calibri"/>
               </a:rPr>
-              <a:t> = at least one uploaded document for the TOC row    |    — Missing = no submitted document</a:t>
+              <a:t> = at least one uploaded document for the TOC row    |    — = no submitted document</a:t>
             </a:r>
           </a:p>
         </p:txBody>
@@ -11656,7 +11650,7 @@
         </p:nvGraphicFramePr>
         <p:xfrm>
           <a:off x="495300" y="1352550"/>
-          <a:ext cx="7810500" cy="4749165"/>
+          <a:ext cx="7810500" cy="5303520"/>
         </p:xfrm>
         <a:graphic>
           <a:graphicData uri="http://schemas.openxmlformats.org/drawingml/2006/table">
@@ -11701,7 +11695,7 @@
                   </a:extLst>
                 </a:gridCol>
               </a:tblGrid>
-              <a:tr h="295275">
+              <a:tr h="310896">
                 <a:tc>
                   <a:txBody>
                     <a:bodyPr/>
@@ -11711,7 +11705,7 @@
                         <a:buNone/>
                       </a:pPr>
                       <a:r>
-                        <a:rPr sz="713" b="1">
+                        <a:rPr sz="1200" b="1">
                           <a:solidFill>
                             <a:srgbClr val="FFFFFF"/>
                           </a:solidFill>
@@ -11738,7 +11732,7 @@
                         <a:buNone/>
                       </a:pPr>
                       <a:r>
-                        <a:rPr sz="713" b="1">
+                        <a:rPr sz="1200" b="1">
                           <a:solidFill>
                             <a:srgbClr val="FFFFFF"/>
                           </a:solidFill>
@@ -11765,7 +11759,7 @@
                         <a:buNone/>
                       </a:pPr>
                       <a:r>
-                        <a:rPr sz="713" b="1">
+                        <a:rPr sz="1200" b="1">
                           <a:solidFill>
                             <a:srgbClr val="FFFFFF"/>
                           </a:solidFill>
@@ -11792,7 +11786,7 @@
                         <a:buNone/>
                       </a:pPr>
                       <a:r>
-                        <a:rPr sz="713" b="1">
+                        <a:rPr sz="1200" b="1">
                           <a:solidFill>
                             <a:srgbClr val="FFFFFF"/>
                           </a:solidFill>
@@ -11819,7 +11813,7 @@
                         <a:buNone/>
                       </a:pPr>
                       <a:r>
-                        <a:rPr sz="713" b="1">
+                        <a:rPr sz="1200" b="1">
                           <a:solidFill>
                             <a:srgbClr val="FFFFFF"/>
                           </a:solidFill>
@@ -11843,7 +11837,7 @@
                   </a:ext>
                 </a:extLst>
               </a:tr>
-              <a:tr h="280035">
+              <a:tr h="310896">
                 <a:tc>
                   <a:txBody>
                     <a:bodyPr/>
@@ -11853,7 +11847,7 @@
                         <a:buNone/>
                       </a:pPr>
                       <a:r>
-                        <a:rPr sz="690" b="0">
+                        <a:rPr sz="1200" b="0">
                           <a:solidFill>
                             <a:srgbClr val="172033"/>
                           </a:solidFill>
@@ -11880,7 +11874,7 @@
                         <a:buNone/>
                       </a:pPr>
                       <a:r>
-                        <a:rPr sz="645" b="1">
+                        <a:rPr sz="1200" b="1">
                           <a:solidFill>
                             <a:srgbClr val="D93A45"/>
                           </a:solidFill>
@@ -11888,7 +11882,7 @@
                           <a:ea typeface="Calibri"/>
                           <a:cs typeface="Calibri"/>
                         </a:rPr>
-                        <a:t>— Missing</a:t>
+                        <a:t>—</a:t>
                       </a:r>
                     </a:p>
                   </a:txBody>
@@ -11907,7 +11901,7 @@
                         <a:buNone/>
                       </a:pPr>
                       <a:r>
-                        <a:rPr sz="645" b="1" dirty="0">
+                        <a:rPr sz="1200" b="1" dirty="0">
                           <a:solidFill>
                             <a:srgbClr val="00A878"/>
                           </a:solidFill>
@@ -11918,7 +11912,7 @@
                         <a:t>✓ </a:t>
                       </a:r>
                       <a:r>
-                        <a:rPr lang="en-US" sz="645" b="1" dirty="0">
+                        <a:rPr lang="en-US" sz="1200" b="1" dirty="0">
                           <a:solidFill>
                             <a:srgbClr val="00A878"/>
                           </a:solidFill>
@@ -11928,7 +11922,7 @@
                         </a:rPr>
                         <a:t>Submitted</a:t>
                       </a:r>
-                      <a:endParaRPr sz="645" b="1" dirty="0">
+                      <a:endParaRPr sz="1200" b="1" dirty="0">
                         <a:solidFill>
                           <a:srgbClr val="00A878"/>
                         </a:solidFill>
@@ -11953,7 +11947,7 @@
                         <a:buNone/>
                       </a:pPr>
                       <a:r>
-                        <a:rPr sz="645" b="1">
+                        <a:rPr sz="1200" b="1">
                           <a:solidFill>
                             <a:srgbClr val="D93A45"/>
                           </a:solidFill>
@@ -11961,7 +11955,7 @@
                           <a:ea typeface="Calibri"/>
                           <a:cs typeface="Calibri"/>
                         </a:rPr>
-                        <a:t>— Missing</a:t>
+                        <a:t>—</a:t>
                       </a:r>
                     </a:p>
                   </a:txBody>
@@ -11980,7 +11974,7 @@
                         <a:buNone/>
                       </a:pPr>
                       <a:r>
-                        <a:rPr sz="645" b="1">
+                        <a:rPr sz="1200" b="1">
                           <a:solidFill>
                             <a:srgbClr val="D93A45"/>
                           </a:solidFill>
@@ -11988,7 +11982,7 @@
                           <a:ea typeface="Calibri"/>
                           <a:cs typeface="Calibri"/>
                         </a:rPr>
-                        <a:t>— Missing</a:t>
+                        <a:t>—</a:t>
                       </a:r>
                     </a:p>
                   </a:txBody>
@@ -12004,7 +11998,7 @@
                   </a:ext>
                 </a:extLst>
               </a:tr>
-              <a:tr h="280035">
+              <a:tr h="310896">
                 <a:tc>
                   <a:txBody>
                     <a:bodyPr/>
@@ -12014,7 +12008,7 @@
                         <a:buNone/>
                       </a:pPr>
                       <a:r>
-                        <a:rPr sz="690" b="0">
+                        <a:rPr sz="1200" b="0">
                           <a:solidFill>
                             <a:srgbClr val="172033"/>
                           </a:solidFill>
@@ -12041,7 +12035,7 @@
                         <a:buNone/>
                       </a:pPr>
                       <a:r>
-                        <a:rPr sz="645" b="1">
+                        <a:rPr sz="1200" b="1">
                           <a:solidFill>
                             <a:srgbClr val="D93A45"/>
                           </a:solidFill>
@@ -12049,7 +12043,7 @@
                           <a:ea typeface="Calibri"/>
                           <a:cs typeface="Calibri"/>
                         </a:rPr>
-                        <a:t>— Missing</a:t>
+                        <a:t>—</a:t>
                       </a:r>
                     </a:p>
                   </a:txBody>
@@ -12068,7 +12062,7 @@
                         <a:buNone/>
                       </a:pPr>
                       <a:r>
-                        <a:rPr lang="en-GB" sz="645" b="1" dirty="0">
+                        <a:rPr lang="en-GB" sz="1200" b="1" dirty="0">
                           <a:solidFill>
                             <a:srgbClr val="00A878"/>
                           </a:solidFill>
@@ -12076,7 +12070,7 @@
                           <a:ea typeface="+mn-ea"/>
                           <a:cs typeface="+mn-cs"/>
                         </a:rPr>
-                        <a:t>✓ Submitted</a:t>
+                        <a:t>✓</a:t>
                       </a:r>
                     </a:p>
                   </a:txBody>
@@ -12095,7 +12089,7 @@
                         <a:buNone/>
                       </a:pPr>
                       <a:r>
-                        <a:rPr lang="en-GB" sz="645" b="1" dirty="0">
+                        <a:rPr lang="en-GB" sz="1200" b="1" dirty="0">
                           <a:solidFill>
                             <a:srgbClr val="00A878"/>
                           </a:solidFill>
@@ -12103,7 +12097,7 @@
                           <a:ea typeface="+mn-ea"/>
                           <a:cs typeface="+mn-cs"/>
                         </a:rPr>
-                        <a:t>✓ Submitted</a:t>
+                        <a:t>✓</a:t>
                       </a:r>
                     </a:p>
                   </a:txBody>
@@ -12122,7 +12116,7 @@
                         <a:buNone/>
                       </a:pPr>
                       <a:r>
-                        <a:rPr sz="645" b="1">
+                        <a:rPr sz="1200" b="1">
                           <a:solidFill>
                             <a:srgbClr val="D93A45"/>
                           </a:solidFill>
@@ -12130,7 +12124,7 @@
                           <a:ea typeface="Calibri"/>
                           <a:cs typeface="Calibri"/>
                         </a:rPr>
-                        <a:t>— Missing</a:t>
+                        <a:t>—</a:t>
                       </a:r>
                     </a:p>
                   </a:txBody>
@@ -12146,7 +12140,7 @@
                   </a:ext>
                 </a:extLst>
               </a:tr>
-              <a:tr h="280035">
+              <a:tr h="310896">
                 <a:tc>
                   <a:txBody>
                     <a:bodyPr/>
@@ -12156,7 +12150,7 @@
                         <a:buNone/>
                       </a:pPr>
                       <a:r>
-                        <a:rPr sz="690" b="0">
+                        <a:rPr sz="1200" b="0">
                           <a:solidFill>
                             <a:srgbClr val="172033"/>
                           </a:solidFill>
@@ -12183,7 +12177,7 @@
                         <a:buNone/>
                       </a:pPr>
                       <a:r>
-                        <a:rPr sz="645" b="1">
+                        <a:rPr sz="1200" b="1">
                           <a:solidFill>
                             <a:srgbClr val="D93A45"/>
                           </a:solidFill>
@@ -12191,7 +12185,7 @@
                           <a:ea typeface="Calibri"/>
                           <a:cs typeface="Calibri"/>
                         </a:rPr>
-                        <a:t>— Missing</a:t>
+                        <a:t>—</a:t>
                       </a:r>
                     </a:p>
                   </a:txBody>
@@ -12210,7 +12204,7 @@
                         <a:buNone/>
                       </a:pPr>
                       <a:r>
-                        <a:rPr lang="en-GB" sz="645" b="1" dirty="0">
+                        <a:rPr lang="en-GB" sz="1200" b="1" dirty="0">
                           <a:solidFill>
                             <a:srgbClr val="00A878"/>
                           </a:solidFill>
@@ -12218,7 +12212,7 @@
                           <a:ea typeface="+mn-ea"/>
                           <a:cs typeface="+mn-cs"/>
                         </a:rPr>
-                        <a:t>✓ Submitted</a:t>
+                        <a:t>✓</a:t>
                       </a:r>
                     </a:p>
                   </a:txBody>
@@ -12237,7 +12231,7 @@
                         <a:buNone/>
                       </a:pPr>
                       <a:r>
-                        <a:rPr sz="645" b="1">
+                        <a:rPr sz="1200" b="1">
                           <a:solidFill>
                             <a:srgbClr val="D93A45"/>
                           </a:solidFill>
@@ -12245,7 +12239,7 @@
                           <a:ea typeface="Calibri"/>
                           <a:cs typeface="Calibri"/>
                         </a:rPr>
-                        <a:t>— Missing</a:t>
+                        <a:t>—</a:t>
                       </a:r>
                     </a:p>
                   </a:txBody>
@@ -12264,7 +12258,7 @@
                         <a:buNone/>
                       </a:pPr>
                       <a:r>
-                        <a:rPr sz="645" b="1">
+                        <a:rPr sz="1200" b="1">
                           <a:solidFill>
                             <a:srgbClr val="D93A45"/>
                           </a:solidFill>
@@ -12272,7 +12266,7 @@
                           <a:ea typeface="Calibri"/>
                           <a:cs typeface="Calibri"/>
                         </a:rPr>
-                        <a:t>— Missing</a:t>
+                        <a:t>—</a:t>
                       </a:r>
                     </a:p>
                   </a:txBody>
@@ -12288,7 +12282,7 @@
                   </a:ext>
                 </a:extLst>
               </a:tr>
-              <a:tr h="280035">
+              <a:tr h="310896">
                 <a:tc>
                   <a:txBody>
                     <a:bodyPr/>
@@ -12298,7 +12292,7 @@
                         <a:buNone/>
                       </a:pPr>
                       <a:r>
-                        <a:rPr sz="690" b="0">
+                        <a:rPr sz="1200" b="0">
                           <a:solidFill>
                             <a:srgbClr val="172033"/>
                           </a:solidFill>
@@ -12325,7 +12319,7 @@
                         <a:buNone/>
                       </a:pPr>
                       <a:r>
-                        <a:rPr sz="645" b="1">
+                        <a:rPr sz="1200" b="1">
                           <a:solidFill>
                             <a:srgbClr val="D93A45"/>
                           </a:solidFill>
@@ -12333,7 +12327,7 @@
                           <a:ea typeface="Calibri"/>
                           <a:cs typeface="Calibri"/>
                         </a:rPr>
-                        <a:t>— Missing</a:t>
+                        <a:t>—</a:t>
                       </a:r>
                     </a:p>
                   </a:txBody>
@@ -12352,7 +12346,7 @@
                         <a:buNone/>
                       </a:pPr>
                       <a:r>
-                        <a:rPr lang="en-GB" sz="645" b="1" dirty="0">
+                        <a:rPr lang="en-GB" sz="1200" b="1" dirty="0">
                           <a:solidFill>
                             <a:srgbClr val="00A878"/>
                           </a:solidFill>
@@ -12360,7 +12354,7 @@
                           <a:ea typeface="+mn-ea"/>
                           <a:cs typeface="+mn-cs"/>
                         </a:rPr>
-                        <a:t>✓ Submitted</a:t>
+                        <a:t>✓</a:t>
                       </a:r>
                     </a:p>
                   </a:txBody>
@@ -12379,7 +12373,7 @@
                         <a:buNone/>
                       </a:pPr>
                       <a:r>
-                        <a:rPr sz="645" b="1">
+                        <a:rPr sz="1200" b="1">
                           <a:solidFill>
                             <a:srgbClr val="D93A45"/>
                           </a:solidFill>
@@ -12387,7 +12381,7 @@
                           <a:ea typeface="Calibri"/>
                           <a:cs typeface="Calibri"/>
                         </a:rPr>
-                        <a:t>— Missing</a:t>
+                        <a:t>—</a:t>
                       </a:r>
                     </a:p>
                   </a:txBody>
@@ -12406,7 +12400,7 @@
                         <a:buNone/>
                       </a:pPr>
                       <a:r>
-                        <a:rPr sz="645" b="1">
+                        <a:rPr sz="1200" b="1">
                           <a:solidFill>
                             <a:srgbClr val="D93A45"/>
                           </a:solidFill>
@@ -12414,7 +12408,7 @@
                           <a:ea typeface="Calibri"/>
                           <a:cs typeface="Calibri"/>
                         </a:rPr>
-                        <a:t>— Missing</a:t>
+                        <a:t>—</a:t>
                       </a:r>
                     </a:p>
                   </a:txBody>
@@ -12430,7 +12424,7 @@
                   </a:ext>
                 </a:extLst>
               </a:tr>
-              <a:tr h="280035">
+              <a:tr h="310896">
                 <a:tc>
                   <a:txBody>
                     <a:bodyPr/>
@@ -12440,7 +12434,7 @@
                         <a:buNone/>
                       </a:pPr>
                       <a:r>
-                        <a:rPr sz="690" b="0">
+                        <a:rPr sz="1200" b="0">
                           <a:solidFill>
                             <a:srgbClr val="172033"/>
                           </a:solidFill>
@@ -12467,7 +12461,7 @@
                         <a:buNone/>
                       </a:pPr>
                       <a:r>
-                        <a:rPr sz="645" b="1">
+                        <a:rPr sz="1200" b="1">
                           <a:solidFill>
                             <a:srgbClr val="D93A45"/>
                           </a:solidFill>
@@ -12475,7 +12469,7 @@
                           <a:ea typeface="Calibri"/>
                           <a:cs typeface="Calibri"/>
                         </a:rPr>
-                        <a:t>— Missing</a:t>
+                        <a:t>—</a:t>
                       </a:r>
                     </a:p>
                   </a:txBody>
@@ -12494,7 +12488,7 @@
                         <a:buNone/>
                       </a:pPr>
                       <a:r>
-                        <a:rPr lang="en-GB" sz="645" b="1" dirty="0">
+                        <a:rPr lang="en-GB" sz="1200" b="1" dirty="0">
                           <a:solidFill>
                             <a:srgbClr val="00A878"/>
                           </a:solidFill>
@@ -12502,7 +12496,7 @@
                           <a:ea typeface="+mn-ea"/>
                           <a:cs typeface="+mn-cs"/>
                         </a:rPr>
-                        <a:t>✓ Submitted</a:t>
+                        <a:t>✓</a:t>
                       </a:r>
                     </a:p>
                   </a:txBody>
@@ -12521,7 +12515,7 @@
                         <a:buNone/>
                       </a:pPr>
                       <a:r>
-                        <a:rPr sz="645" b="1" dirty="0">
+                        <a:rPr sz="1200" b="1" dirty="0">
                           <a:solidFill>
                             <a:srgbClr val="D93A45"/>
                           </a:solidFill>
@@ -12529,7 +12523,7 @@
                           <a:ea typeface="Calibri"/>
                           <a:cs typeface="Calibri"/>
                         </a:rPr>
-                        <a:t>— Missing</a:t>
+                        <a:t>—</a:t>
                       </a:r>
                     </a:p>
                   </a:txBody>
@@ -12548,7 +12542,7 @@
                         <a:buNone/>
                       </a:pPr>
                       <a:r>
-                        <a:rPr sz="645" b="1">
+                        <a:rPr sz="1200" b="1">
                           <a:solidFill>
                             <a:srgbClr val="D93A45"/>
                           </a:solidFill>
@@ -12556,7 +12550,7 @@
                           <a:ea typeface="Calibri"/>
                           <a:cs typeface="Calibri"/>
                         </a:rPr>
-                        <a:t>— Missing</a:t>
+                        <a:t>—</a:t>
                       </a:r>
                     </a:p>
                   </a:txBody>
@@ -12572,7 +12566,7 @@
                   </a:ext>
                 </a:extLst>
               </a:tr>
-              <a:tr h="280035">
+              <a:tr h="310896">
                 <a:tc>
                   <a:txBody>
                     <a:bodyPr/>
@@ -12582,7 +12576,7 @@
                         <a:buNone/>
                       </a:pPr>
                       <a:r>
-                        <a:rPr sz="690" b="0">
+                        <a:rPr sz="1200" b="0">
                           <a:solidFill>
                             <a:srgbClr val="172033"/>
                           </a:solidFill>
@@ -12609,7 +12603,7 @@
                         <a:buNone/>
                       </a:pPr>
                       <a:r>
-                        <a:rPr sz="645" b="1">
+                        <a:rPr sz="1200" b="1">
                           <a:solidFill>
                             <a:srgbClr val="D93A45"/>
                           </a:solidFill>
@@ -12617,7 +12611,7 @@
                           <a:ea typeface="Calibri"/>
                           <a:cs typeface="Calibri"/>
                         </a:rPr>
-                        <a:t>— Missing</a:t>
+                        <a:t>—</a:t>
                       </a:r>
                     </a:p>
                   </a:txBody>
@@ -12636,7 +12630,7 @@
                         <a:buNone/>
                       </a:pPr>
                       <a:r>
-                        <a:rPr lang="en-GB" sz="645" b="1" dirty="0">
+                        <a:rPr lang="en-GB" sz="1200" b="1" dirty="0">
                           <a:solidFill>
                             <a:srgbClr val="00A878"/>
                           </a:solidFill>
@@ -12644,7 +12638,7 @@
                           <a:ea typeface="+mn-ea"/>
                           <a:cs typeface="+mn-cs"/>
                         </a:rPr>
-                        <a:t>✓ Submitted</a:t>
+                        <a:t>✓</a:t>
                       </a:r>
                     </a:p>
                   </a:txBody>
@@ -12663,7 +12657,7 @@
                         <a:buNone/>
                       </a:pPr>
                       <a:r>
-                        <a:rPr sz="645" b="1" dirty="0">
+                        <a:rPr sz="1200" b="1" dirty="0">
                           <a:solidFill>
                             <a:srgbClr val="D93A45"/>
                           </a:solidFill>
@@ -12671,7 +12665,7 @@
                           <a:ea typeface="Calibri"/>
                           <a:cs typeface="Calibri"/>
                         </a:rPr>
-                        <a:t>— Missing</a:t>
+                        <a:t>—</a:t>
                       </a:r>
                     </a:p>
                   </a:txBody>
@@ -12690,7 +12684,7 @@
                         <a:buNone/>
                       </a:pPr>
                       <a:r>
-                        <a:rPr sz="645" b="1">
+                        <a:rPr sz="1200" b="1">
                           <a:solidFill>
                             <a:srgbClr val="D93A45"/>
                           </a:solidFill>
@@ -12698,7 +12692,7 @@
                           <a:ea typeface="Calibri"/>
                           <a:cs typeface="Calibri"/>
                         </a:rPr>
-                        <a:t>— Missing</a:t>
+                        <a:t>—</a:t>
                       </a:r>
                     </a:p>
                   </a:txBody>
@@ -12714,7 +12708,7 @@
                   </a:ext>
                 </a:extLst>
               </a:tr>
-              <a:tr h="280035">
+              <a:tr h="310896">
                 <a:tc>
                   <a:txBody>
                     <a:bodyPr/>
@@ -12724,7 +12718,7 @@
                         <a:buNone/>
                       </a:pPr>
                       <a:r>
-                        <a:rPr sz="690" b="0">
+                        <a:rPr sz="1200" b="0">
                           <a:solidFill>
                             <a:srgbClr val="172033"/>
                           </a:solidFill>
@@ -12751,7 +12745,7 @@
                         <a:buNone/>
                       </a:pPr>
                       <a:r>
-                        <a:rPr sz="645" b="1" dirty="0">
+                        <a:rPr sz="1200" b="1" dirty="0">
                           <a:solidFill>
                             <a:srgbClr val="D93A45"/>
                           </a:solidFill>
@@ -12759,7 +12753,7 @@
                           <a:ea typeface="Calibri"/>
                           <a:cs typeface="Calibri"/>
                         </a:rPr>
-                        <a:t>— Missing</a:t>
+                        <a:t>—</a:t>
                       </a:r>
                     </a:p>
                   </a:txBody>
@@ -12778,7 +12772,7 @@
                         <a:buNone/>
                       </a:pPr>
                       <a:r>
-                        <a:rPr lang="en-GB" sz="645" b="1" dirty="0">
+                        <a:rPr lang="en-GB" sz="1200" b="1" dirty="0">
                           <a:solidFill>
                             <a:srgbClr val="00A878"/>
                           </a:solidFill>
@@ -12786,7 +12780,7 @@
                           <a:ea typeface="+mn-ea"/>
                           <a:cs typeface="+mn-cs"/>
                         </a:rPr>
-                        <a:t>✓ Submitted</a:t>
+                        <a:t>✓</a:t>
                       </a:r>
                     </a:p>
                   </a:txBody>
@@ -12805,7 +12799,7 @@
                         <a:buNone/>
                       </a:pPr>
                       <a:r>
-                        <a:rPr lang="en-GB" sz="645" b="1" dirty="0">
+                        <a:rPr lang="en-GB" sz="1200" b="1" dirty="0">
                           <a:solidFill>
                             <a:srgbClr val="00A878"/>
                           </a:solidFill>
@@ -12813,7 +12807,7 @@
                           <a:ea typeface="+mn-ea"/>
                           <a:cs typeface="+mn-cs"/>
                         </a:rPr>
-                        <a:t>✓ Submitted</a:t>
+                        <a:t>✓</a:t>
                       </a:r>
                     </a:p>
                   </a:txBody>
@@ -12832,7 +12826,7 @@
                         <a:buNone/>
                       </a:pPr>
                       <a:r>
-                        <a:rPr sz="645" b="1">
+                        <a:rPr sz="1200" b="1">
                           <a:solidFill>
                             <a:srgbClr val="D93A45"/>
                           </a:solidFill>
@@ -12840,7 +12834,7 @@
                           <a:ea typeface="Calibri"/>
                           <a:cs typeface="Calibri"/>
                         </a:rPr>
-                        <a:t>— Missing</a:t>
+                        <a:t>—</a:t>
                       </a:r>
                     </a:p>
                   </a:txBody>
@@ -12856,7 +12850,7 @@
                   </a:ext>
                 </a:extLst>
               </a:tr>
-              <a:tr h="280035">
+              <a:tr h="310896">
                 <a:tc>
                   <a:txBody>
                     <a:bodyPr/>
@@ -12866,7 +12860,7 @@
                         <a:buNone/>
                       </a:pPr>
                       <a:r>
-                        <a:rPr sz="690" b="0">
+                        <a:rPr sz="1200" b="0">
                           <a:solidFill>
                             <a:srgbClr val="172033"/>
                           </a:solidFill>
@@ -12893,7 +12887,7 @@
                         <a:buNone/>
                       </a:pPr>
                       <a:r>
-                        <a:rPr lang="en-GB" sz="645" b="1" dirty="0">
+                        <a:rPr lang="en-GB" sz="1200" b="1" dirty="0">
                           <a:solidFill>
                             <a:srgbClr val="00A878"/>
                           </a:solidFill>
@@ -12901,7 +12895,7 @@
                           <a:ea typeface="+mn-ea"/>
                           <a:cs typeface="+mn-cs"/>
                         </a:rPr>
-                        <a:t>✓ Submitted</a:t>
+                        <a:t>✓</a:t>
                       </a:r>
                     </a:p>
                   </a:txBody>
@@ -12920,7 +12914,7 @@
                         <a:buNone/>
                       </a:pPr>
                       <a:r>
-                        <a:rPr lang="en-GB" sz="645" b="1" dirty="0">
+                        <a:rPr lang="en-GB" sz="1200" b="1" dirty="0">
                           <a:solidFill>
                             <a:srgbClr val="00A878"/>
                           </a:solidFill>
@@ -12928,7 +12922,7 @@
                           <a:ea typeface="+mn-ea"/>
                           <a:cs typeface="+mn-cs"/>
                         </a:rPr>
-                        <a:t>✓ Submitted</a:t>
+                        <a:t>✓</a:t>
                       </a:r>
                     </a:p>
                   </a:txBody>
@@ -12947,7 +12941,7 @@
                         <a:buNone/>
                       </a:pPr>
                       <a:r>
-                        <a:rPr lang="en-GB" sz="645" b="1" dirty="0">
+                        <a:rPr lang="en-GB" sz="1200" b="1" dirty="0">
                           <a:solidFill>
                             <a:srgbClr val="00A878"/>
                           </a:solidFill>
@@ -12955,7 +12949,7 @@
                           <a:ea typeface="+mn-ea"/>
                           <a:cs typeface="+mn-cs"/>
                         </a:rPr>
-                        <a:t>✓ Submitted</a:t>
+                        <a:t>✓</a:t>
                       </a:r>
                     </a:p>
                   </a:txBody>
@@ -12974,7 +12968,7 @@
                         <a:buNone/>
                       </a:pPr>
                       <a:r>
-                        <a:rPr lang="en-GB" sz="645" b="1" dirty="0">
+                        <a:rPr lang="en-GB" sz="1200" b="1" dirty="0">
                           <a:solidFill>
                             <a:srgbClr val="00A878"/>
                           </a:solidFill>
@@ -12982,7 +12976,7 @@
                           <a:ea typeface="+mn-ea"/>
                           <a:cs typeface="+mn-cs"/>
                         </a:rPr>
-                        <a:t>✓ Submitted</a:t>
+                        <a:t>✓</a:t>
                       </a:r>
                     </a:p>
                   </a:txBody>
@@ -12998,7 +12992,7 @@
                   </a:ext>
                 </a:extLst>
               </a:tr>
-              <a:tr h="280035">
+              <a:tr h="310896">
                 <a:tc>
                   <a:txBody>
                     <a:bodyPr/>
@@ -13008,7 +13002,7 @@
                         <a:buNone/>
                       </a:pPr>
                       <a:r>
-                        <a:rPr sz="690" b="0">
+                        <a:rPr sz="1200" b="0">
                           <a:solidFill>
                             <a:srgbClr val="172033"/>
                           </a:solidFill>
@@ -13035,7 +13029,7 @@
                         <a:buNone/>
                       </a:pPr>
                       <a:r>
-                        <a:rPr lang="en-GB" sz="645" b="1" dirty="0">
+                        <a:rPr lang="en-GB" sz="1200" b="1" dirty="0">
                           <a:solidFill>
                             <a:srgbClr val="D93A45"/>
                           </a:solidFill>
@@ -13043,7 +13037,7 @@
                           <a:ea typeface="+mn-ea"/>
                           <a:cs typeface="+mn-cs"/>
                         </a:rPr>
-                        <a:t>— Missing</a:t>
+                        <a:t>—</a:t>
                       </a:r>
                     </a:p>
                   </a:txBody>
@@ -13062,7 +13056,7 @@
                         <a:buNone/>
                       </a:pPr>
                       <a:r>
-                        <a:rPr lang="en-GB" sz="645" b="1" dirty="0">
+                        <a:rPr lang="en-GB" sz="1200" b="1" dirty="0">
                           <a:solidFill>
                             <a:srgbClr val="D93A45"/>
                           </a:solidFill>
@@ -13070,7 +13064,7 @@
                           <a:ea typeface="+mn-ea"/>
                           <a:cs typeface="+mn-cs"/>
                         </a:rPr>
-                        <a:t>— Missing</a:t>
+                        <a:t>—</a:t>
                       </a:r>
                     </a:p>
                   </a:txBody>
@@ -13089,7 +13083,7 @@
                         <a:buNone/>
                       </a:pPr>
                       <a:r>
-                        <a:rPr lang="en-GB" sz="645" b="1" dirty="0">
+                        <a:rPr lang="en-GB" sz="1200" b="1" dirty="0">
                           <a:solidFill>
                             <a:srgbClr val="D93A45"/>
                           </a:solidFill>
@@ -13097,7 +13091,7 @@
                           <a:ea typeface="+mn-ea"/>
                           <a:cs typeface="+mn-cs"/>
                         </a:rPr>
-                        <a:t>— Missing</a:t>
+                        <a:t>—</a:t>
                       </a:r>
                     </a:p>
                   </a:txBody>
@@ -13116,7 +13110,7 @@
                         <a:buNone/>
                       </a:pPr>
                       <a:r>
-                        <a:rPr sz="645" b="1">
+                        <a:rPr sz="1200" b="1">
                           <a:solidFill>
                             <a:srgbClr val="D93A45"/>
                           </a:solidFill>
@@ -13124,7 +13118,7 @@
                           <a:ea typeface="Calibri"/>
                           <a:cs typeface="Calibri"/>
                         </a:rPr>
-                        <a:t>— Missing</a:t>
+                        <a:t>—</a:t>
                       </a:r>
                     </a:p>
                   </a:txBody>
@@ -13140,7 +13134,7 @@
                   </a:ext>
                 </a:extLst>
               </a:tr>
-              <a:tr h="280035">
+              <a:tr h="310896">
                 <a:tc>
                   <a:txBody>
                     <a:bodyPr/>
@@ -13150,7 +13144,7 @@
                         <a:buNone/>
                       </a:pPr>
                       <a:r>
-                        <a:rPr sz="690" b="0">
+                        <a:rPr sz="1200" b="0">
                           <a:solidFill>
                             <a:srgbClr val="172033"/>
                           </a:solidFill>
@@ -13177,7 +13171,7 @@
                         <a:buNone/>
                       </a:pPr>
                       <a:r>
-                        <a:rPr sz="645" b="1" dirty="0">
+                        <a:rPr sz="1200" b="1" dirty="0">
                           <a:solidFill>
                             <a:srgbClr val="D93A45"/>
                           </a:solidFill>
@@ -13185,7 +13179,7 @@
                           <a:ea typeface="Calibri"/>
                           <a:cs typeface="Calibri"/>
                         </a:rPr>
-                        <a:t>— Missing</a:t>
+                        <a:t>—</a:t>
                       </a:r>
                     </a:p>
                   </a:txBody>
@@ -13204,7 +13198,7 @@
                         <a:buNone/>
                       </a:pPr>
                       <a:r>
-                        <a:rPr lang="en-GB" sz="645" b="1" dirty="0">
+                        <a:rPr lang="en-GB" sz="1200" b="1" dirty="0">
                           <a:solidFill>
                             <a:srgbClr val="00A878"/>
                           </a:solidFill>
@@ -13212,7 +13206,7 @@
                           <a:ea typeface="+mn-ea"/>
                           <a:cs typeface="+mn-cs"/>
                         </a:rPr>
-                        <a:t>✓ Submitted</a:t>
+                        <a:t>✓</a:t>
                       </a:r>
                     </a:p>
                   </a:txBody>
@@ -13231,7 +13225,7 @@
                         <a:buNone/>
                       </a:pPr>
                       <a:r>
-                        <a:rPr sz="645" b="1" dirty="0">
+                        <a:rPr sz="1200" b="1" dirty="0">
                           <a:solidFill>
                             <a:srgbClr val="D93A45"/>
                           </a:solidFill>
@@ -13239,7 +13233,7 @@
                           <a:ea typeface="Calibri"/>
                           <a:cs typeface="Calibri"/>
                         </a:rPr>
-                        <a:t>— Missing</a:t>
+                        <a:t>—</a:t>
                       </a:r>
                     </a:p>
                   </a:txBody>
@@ -13258,7 +13252,7 @@
                         <a:buNone/>
                       </a:pPr>
                       <a:r>
-                        <a:rPr sz="645" b="1">
+                        <a:rPr sz="1200" b="1">
                           <a:solidFill>
                             <a:srgbClr val="D93A45"/>
                           </a:solidFill>
@@ -13266,7 +13260,7 @@
                           <a:ea typeface="Calibri"/>
                           <a:cs typeface="Calibri"/>
                         </a:rPr>
-                        <a:t>— Missing</a:t>
+                        <a:t>—</a:t>
                       </a:r>
                     </a:p>
                   </a:txBody>
@@ -13282,7 +13276,7 @@
                   </a:ext>
                 </a:extLst>
               </a:tr>
-              <a:tr h="280035">
+              <a:tr h="310896">
                 <a:tc>
                   <a:txBody>
                     <a:bodyPr/>
@@ -13292,7 +13286,7 @@
                         <a:buNone/>
                       </a:pPr>
                       <a:r>
-                        <a:rPr sz="690" b="0">
+                        <a:rPr sz="1200" b="0">
                           <a:solidFill>
                             <a:srgbClr val="172033"/>
                           </a:solidFill>
@@ -13319,7 +13313,7 @@
                         <a:buNone/>
                       </a:pPr>
                       <a:r>
-                        <a:rPr lang="en-GB" sz="645" b="1" dirty="0">
+                        <a:rPr lang="en-GB" sz="1200" b="1" dirty="0">
                           <a:solidFill>
                             <a:srgbClr val="00A878"/>
                           </a:solidFill>
@@ -13327,7 +13321,7 @@
                           <a:ea typeface="+mn-ea"/>
                           <a:cs typeface="+mn-cs"/>
                         </a:rPr>
-                        <a:t>✓ Submitted</a:t>
+                        <a:t>✓</a:t>
                       </a:r>
                     </a:p>
                   </a:txBody>
@@ -13346,7 +13340,7 @@
                         <a:buNone/>
                       </a:pPr>
                       <a:r>
-                        <a:rPr lang="en-GB" sz="645" b="1" dirty="0">
+                        <a:rPr lang="en-GB" sz="1200" b="1" dirty="0">
                           <a:solidFill>
                             <a:srgbClr val="00A878"/>
                           </a:solidFill>
@@ -13354,7 +13348,7 @@
                           <a:ea typeface="+mn-ea"/>
                           <a:cs typeface="+mn-cs"/>
                         </a:rPr>
-                        <a:t>✓ Submitted</a:t>
+                        <a:t>✓</a:t>
                       </a:r>
                     </a:p>
                   </a:txBody>
@@ -13373,7 +13367,7 @@
                         <a:buNone/>
                       </a:pPr>
                       <a:r>
-                        <a:rPr sz="645" b="1">
+                        <a:rPr sz="1200" b="1">
                           <a:solidFill>
                             <a:srgbClr val="D93A45"/>
                           </a:solidFill>
@@ -13381,7 +13375,7 @@
                           <a:ea typeface="Calibri"/>
                           <a:cs typeface="Calibri"/>
                         </a:rPr>
-                        <a:t>— Missing</a:t>
+                        <a:t>—</a:t>
                       </a:r>
                     </a:p>
                   </a:txBody>
@@ -13400,7 +13394,7 @@
                         <a:buNone/>
                       </a:pPr>
                       <a:r>
-                        <a:rPr sz="645" b="1">
+                        <a:rPr sz="1200" b="1">
                           <a:solidFill>
                             <a:srgbClr val="D93A45"/>
                           </a:solidFill>
@@ -13408,7 +13402,7 @@
                           <a:ea typeface="Calibri"/>
                           <a:cs typeface="Calibri"/>
                         </a:rPr>
-                        <a:t>— Missing</a:t>
+                        <a:t>—</a:t>
                       </a:r>
                     </a:p>
                   </a:txBody>
@@ -13424,7 +13418,7 @@
                   </a:ext>
                 </a:extLst>
               </a:tr>
-              <a:tr h="280035">
+              <a:tr h="310896">
                 <a:tc>
                   <a:txBody>
                     <a:bodyPr/>
@@ -13434,7 +13428,7 @@
                         <a:buNone/>
                       </a:pPr>
                       <a:r>
-                        <a:rPr sz="690" b="0">
+                        <a:rPr sz="1200" b="0">
                           <a:solidFill>
                             <a:srgbClr val="172033"/>
                           </a:solidFill>
@@ -13461,7 +13455,7 @@
                         <a:buNone/>
                       </a:pPr>
                       <a:r>
-                        <a:rPr lang="en-GB" sz="645" b="1" dirty="0">
+                        <a:rPr lang="en-GB" sz="1200" b="1" dirty="0">
                           <a:solidFill>
                             <a:srgbClr val="00A878"/>
                           </a:solidFill>
@@ -13469,7 +13463,7 @@
                           <a:ea typeface="+mn-ea"/>
                           <a:cs typeface="+mn-cs"/>
                         </a:rPr>
-                        <a:t>✓ Submitted</a:t>
+                        <a:t>✓</a:t>
                       </a:r>
                     </a:p>
                   </a:txBody>
@@ -13488,7 +13482,7 @@
                         <a:buNone/>
                       </a:pPr>
                       <a:r>
-                        <a:rPr lang="en-GB" sz="645" b="1" dirty="0">
+                        <a:rPr lang="en-GB" sz="1200" b="1" dirty="0">
                           <a:solidFill>
                             <a:srgbClr val="00A878"/>
                           </a:solidFill>
@@ -13496,7 +13490,7 @@
                           <a:ea typeface="+mn-ea"/>
                           <a:cs typeface="+mn-cs"/>
                         </a:rPr>
-                        <a:t>✓ Submitted</a:t>
+                        <a:t>✓</a:t>
                       </a:r>
                     </a:p>
                   </a:txBody>
@@ -13515,7 +13509,7 @@
                         <a:buNone/>
                       </a:pPr>
                       <a:r>
-                        <a:rPr lang="en-GB" sz="645" b="1" dirty="0">
+                        <a:rPr lang="en-GB" sz="1200" b="1" dirty="0">
                           <a:solidFill>
                             <a:srgbClr val="00A878"/>
                           </a:solidFill>
@@ -13523,7 +13517,7 @@
                           <a:ea typeface="+mn-ea"/>
                           <a:cs typeface="+mn-cs"/>
                         </a:rPr>
-                        <a:t>✓ Submitted</a:t>
+                        <a:t>✓</a:t>
                       </a:r>
                     </a:p>
                   </a:txBody>
@@ -13542,7 +13536,7 @@
                         <a:buNone/>
                       </a:pPr>
                       <a:r>
-                        <a:rPr sz="645" b="1" dirty="0">
+                        <a:rPr sz="1200" b="1" dirty="0">
                           <a:solidFill>
                             <a:srgbClr val="D93A45"/>
                           </a:solidFill>
@@ -13550,7 +13544,7 @@
                           <a:ea typeface="Calibri"/>
                           <a:cs typeface="Calibri"/>
                         </a:rPr>
-                        <a:t>— Missing</a:t>
+                        <a:t>—</a:t>
                       </a:r>
                     </a:p>
                   </a:txBody>
@@ -13566,7 +13560,7 @@
                   </a:ext>
                 </a:extLst>
               </a:tr>
-              <a:tr h="280035">
+              <a:tr h="310896">
                 <a:tc>
                   <a:txBody>
                     <a:bodyPr/>
@@ -13576,7 +13570,7 @@
                         <a:buNone/>
                       </a:pPr>
                       <a:r>
-                        <a:rPr sz="690" b="0">
+                        <a:rPr sz="1200" b="0">
                           <a:solidFill>
                             <a:srgbClr val="172033"/>
                           </a:solidFill>
@@ -13603,7 +13597,7 @@
                         <a:buNone/>
                       </a:pPr>
                       <a:r>
-                        <a:rPr lang="en-GB" sz="645" b="1" dirty="0">
+                        <a:rPr lang="en-GB" sz="1200" b="1" dirty="0">
                           <a:solidFill>
                             <a:srgbClr val="D93A45"/>
                           </a:solidFill>
@@ -13611,7 +13605,7 @@
                           <a:ea typeface="+mn-ea"/>
                           <a:cs typeface="+mn-cs"/>
                         </a:rPr>
-                        <a:t>— Missing</a:t>
+                        <a:t>—</a:t>
                       </a:r>
                     </a:p>
                   </a:txBody>
@@ -13630,7 +13624,7 @@
                         <a:buNone/>
                       </a:pPr>
                       <a:r>
-                        <a:rPr sz="645" b="1">
+                        <a:rPr sz="1200" b="1">
                           <a:solidFill>
                             <a:srgbClr val="D93A45"/>
                           </a:solidFill>
@@ -13638,7 +13632,7 @@
                           <a:ea typeface="Calibri"/>
                           <a:cs typeface="Calibri"/>
                         </a:rPr>
-                        <a:t>— Missing</a:t>
+                        <a:t>—</a:t>
                       </a:r>
                     </a:p>
                   </a:txBody>
@@ -13657,7 +13651,7 @@
                         <a:buNone/>
                       </a:pPr>
                       <a:r>
-                        <a:rPr sz="645" b="1">
+                        <a:rPr sz="1200" b="1">
                           <a:solidFill>
                             <a:srgbClr val="D93A45"/>
                           </a:solidFill>
@@ -13665,7 +13659,7 @@
                           <a:ea typeface="Calibri"/>
                           <a:cs typeface="Calibri"/>
                         </a:rPr>
-                        <a:t>— Missing</a:t>
+                        <a:t>—</a:t>
                       </a:r>
                     </a:p>
                   </a:txBody>
@@ -13684,7 +13678,7 @@
                         <a:buNone/>
                       </a:pPr>
                       <a:r>
-                        <a:rPr sz="645" b="1">
+                        <a:rPr sz="1200" b="1">
                           <a:solidFill>
                             <a:srgbClr val="D93A45"/>
                           </a:solidFill>
@@ -13692,7 +13686,7 @@
                           <a:ea typeface="Calibri"/>
                           <a:cs typeface="Calibri"/>
                         </a:rPr>
-                        <a:t>— Missing</a:t>
+                        <a:t>—</a:t>
                       </a:r>
                     </a:p>
                   </a:txBody>
@@ -13708,7 +13702,7 @@
                   </a:ext>
                 </a:extLst>
               </a:tr>
-              <a:tr h="280035">
+              <a:tr h="310896">
                 <a:tc>
                   <a:txBody>
                     <a:bodyPr/>
@@ -13718,7 +13712,7 @@
                         <a:buNone/>
                       </a:pPr>
                       <a:r>
-                        <a:rPr sz="690" b="0">
+                        <a:rPr sz="1200" b="0">
                           <a:solidFill>
                             <a:srgbClr val="172033"/>
                           </a:solidFill>
@@ -13745,7 +13739,7 @@
                         <a:buNone/>
                       </a:pPr>
                       <a:r>
-                        <a:rPr sz="645" b="1">
+                        <a:rPr sz="1200" b="1">
                           <a:solidFill>
                             <a:srgbClr val="D93A45"/>
                           </a:solidFill>
@@ -13753,7 +13747,7 @@
                           <a:ea typeface="Calibri"/>
                           <a:cs typeface="Calibri"/>
                         </a:rPr>
-                        <a:t>— Missing</a:t>
+                        <a:t>—</a:t>
                       </a:r>
                     </a:p>
                   </a:txBody>
@@ -13772,7 +13766,7 @@
                         <a:buNone/>
                       </a:pPr>
                       <a:r>
-                        <a:rPr sz="645" b="1">
+                        <a:rPr sz="1200" b="1">
                           <a:solidFill>
                             <a:srgbClr val="D93A45"/>
                           </a:solidFill>
@@ -13780,7 +13774,7 @@
                           <a:ea typeface="Calibri"/>
                           <a:cs typeface="Calibri"/>
                         </a:rPr>
-                        <a:t>— Missing</a:t>
+                        <a:t>—</a:t>
                       </a:r>
                     </a:p>
                   </a:txBody>
@@ -13799,7 +13793,7 @@
                         <a:buNone/>
                       </a:pPr>
                       <a:r>
-                        <a:rPr sz="645" b="1">
+                        <a:rPr sz="1200" b="1">
                           <a:solidFill>
                             <a:srgbClr val="D93A45"/>
                           </a:solidFill>
@@ -13807,7 +13801,7 @@
                           <a:ea typeface="Calibri"/>
                           <a:cs typeface="Calibri"/>
                         </a:rPr>
-                        <a:t>— Missing</a:t>
+                        <a:t>—</a:t>
                       </a:r>
                     </a:p>
                   </a:txBody>
@@ -13826,7 +13820,7 @@
                         <a:buNone/>
                       </a:pPr>
                       <a:r>
-                        <a:rPr sz="645" b="1">
+                        <a:rPr sz="1200" b="1">
                           <a:solidFill>
                             <a:srgbClr val="D93A45"/>
                           </a:solidFill>
@@ -13834,7 +13828,7 @@
                           <a:ea typeface="Calibri"/>
                           <a:cs typeface="Calibri"/>
                         </a:rPr>
-                        <a:t>— Missing</a:t>
+                        <a:t>—</a:t>
                       </a:r>
                     </a:p>
                   </a:txBody>
@@ -13850,7 +13844,7 @@
                   </a:ext>
                 </a:extLst>
               </a:tr>
-              <a:tr h="266700">
+              <a:tr h="310896">
                 <a:tc>
                   <a:txBody>
                     <a:bodyPr/>
@@ -13860,7 +13854,7 @@
                         <a:buNone/>
                       </a:pPr>
                       <a:r>
-                        <a:rPr sz="750" b="1">
+                        <a:rPr sz="1200" b="1">
                           <a:solidFill>
                             <a:srgbClr val="071B3D"/>
                           </a:solidFill>
@@ -13887,7 +13881,7 @@
                         <a:buNone/>
                       </a:pPr>
                       <a:r>
-                        <a:rPr sz="750" b="1">
+                        <a:rPr sz="1200" b="1">
                           <a:solidFill>
                             <a:srgbClr val="D69B00"/>
                           </a:solidFill>
@@ -13914,7 +13908,7 @@
                         <a:buNone/>
                       </a:pPr>
                       <a:r>
-                        <a:rPr sz="750" b="1">
+                        <a:rPr sz="1200" b="1">
                           <a:solidFill>
                             <a:srgbClr val="00A878"/>
                           </a:solidFill>
@@ -13941,7 +13935,7 @@
                         <a:buNone/>
                       </a:pPr>
                       <a:r>
-                        <a:rPr sz="750" b="1">
+                        <a:rPr sz="1200" b="1">
                           <a:solidFill>
                             <a:srgbClr val="D69B00"/>
                           </a:solidFill>
@@ -13968,7 +13962,7 @@
                         <a:buNone/>
                       </a:pPr>
                       <a:r>
-                        <a:rPr sz="750" b="1">
+                        <a:rPr sz="1200" b="1">
                           <a:solidFill>
                             <a:srgbClr val="D93A45"/>
                           </a:solidFill>
@@ -13992,7 +13986,7 @@
                   </a:ext>
                 </a:extLst>
               </a:tr>
-              <a:tr h="266700">
+              <a:tr h="310896">
                 <a:tc>
                   <a:txBody>
                     <a:bodyPr/>
@@ -14002,7 +13996,7 @@
                         <a:buNone/>
                       </a:pPr>
                       <a:r>
-                        <a:rPr sz="750" b="1">
+                        <a:rPr sz="1200" b="1">
                           <a:solidFill>
                             <a:srgbClr val="071B3D"/>
                           </a:solidFill>
@@ -14029,7 +14023,7 @@
                         <a:buNone/>
                       </a:pPr>
                       <a:r>
-                        <a:rPr sz="750" b="1">
+                        <a:rPr sz="1200" b="1">
                           <a:solidFill>
                             <a:srgbClr val="D69B00"/>
                           </a:solidFill>
@@ -14056,7 +14050,7 @@
                         <a:buNone/>
                       </a:pPr>
                       <a:r>
-                        <a:rPr sz="750" b="1">
+                        <a:rPr sz="1200" b="1">
                           <a:solidFill>
                             <a:srgbClr val="00A878"/>
                           </a:solidFill>
@@ -14083,7 +14077,7 @@
                         <a:buNone/>
                       </a:pPr>
                       <a:r>
-                        <a:rPr sz="750" b="1">
+                        <a:rPr sz="1200" b="1">
                           <a:solidFill>
                             <a:srgbClr val="D69B00"/>
                           </a:solidFill>
@@ -14110,7 +14104,7 @@
                         <a:buNone/>
                       </a:pPr>
                       <a:r>
-                        <a:rPr sz="750" b="1" dirty="0">
+                        <a:rPr sz="1200" b="1" dirty="0">
                           <a:solidFill>
                             <a:srgbClr val="D93A45"/>
                           </a:solidFill>
@@ -14155,7 +14149,7 @@
         <p:spPr>
           <a:xfrm>
             <a:off x="8515350" y="4953000"/>
-            <a:ext cx="3105150" cy="933450"/>
+            <a:ext cx="3105150" cy="1143000"/>
           </a:xfrm>
           <a:prstGeom prst="roundRect">
             <a:avLst>
@@ -14173,14 +14167,12 @@
           </a:ln>
         </p:spPr>
         <p:txBody>
-          <a:bodyPr lIns="133350" tIns="76200" rIns="114300" bIns="76200" anchor="ctr">
-            <a:spAutoFit/>
-          </a:bodyPr>
+          <a:bodyPr lIns="133350" tIns="76200" rIns="114300" bIns="76200" anchor="ctr"/>
           <a:lstStyle/>
           <a:p>
             <a:pPr algn="l">
               <a:buNone/>
-              <a:defRPr sz="900" b="0">
+              <a:defRPr sz="1200" b="0">
                 <a:solidFill>
                   <a:srgbClr val="071B3D"/>
                 </a:solidFill>
@@ -14190,7 +14182,7 @@
               </a:defRPr>
             </a:pPr>
             <a:r>
-              <a:rPr sz="900" b="0">
+              <a:rPr sz="1200" b="0">
                 <a:solidFill>
                   <a:srgbClr val="071B3D"/>
                 </a:solidFill>
@@ -14204,7 +14196,7 @@
           <a:p>
             <a:pPr algn="l">
               <a:buNone/>
-              <a:defRPr sz="900" b="0">
+              <a:defRPr sz="1200" b="0">
                 <a:solidFill>
                   <a:srgbClr val="071B3D"/>
                 </a:solidFill>
@@ -14214,7 +14206,7 @@
               </a:defRPr>
             </a:pPr>
             <a:r>
-              <a:rPr sz="900" b="0">
+              <a:rPr sz="1200" b="0">
                 <a:solidFill>
                   <a:srgbClr val="071B3D"/>
                 </a:solidFill>
@@ -14228,7 +14220,7 @@
           <a:p>
             <a:pPr algn="l">
               <a:buNone/>
-              <a:defRPr sz="900" b="0">
+              <a:defRPr sz="1200" b="0">
                 <a:solidFill>
                   <a:srgbClr val="071B3D"/>
                 </a:solidFill>
@@ -14238,7 +14230,7 @@
               </a:defRPr>
             </a:pPr>
             <a:r>
-              <a:rPr sz="900" b="0">
+              <a:rPr sz="1200" b="0">
                 <a:solidFill>
                   <a:srgbClr val="071B3D"/>
                 </a:solidFill>
@@ -14252,7 +14244,7 @@
           <a:p>
             <a:pPr algn="l">
               <a:buNone/>
-              <a:defRPr sz="900" b="0">
+              <a:defRPr sz="1200" b="0">
                 <a:solidFill>
                   <a:srgbClr val="071B3D"/>
                 </a:solidFill>
@@ -14262,7 +14254,7 @@
               </a:defRPr>
             </a:pPr>
             <a:r>
-              <a:rPr sz="900" b="0">
+              <a:rPr sz="1200" b="0">
                 <a:solidFill>
                   <a:srgbClr val="071B3D"/>
                 </a:solidFill>
@@ -14415,7 +14407,7 @@
           <a:lstStyle/>
           <a:p>
             <a:pPr algn="l">
-              <a:defRPr sz="1125" b="1">
+              <a:defRPr sz="1200" b="1">
                 <a:solidFill>
                   <a:srgbClr val="071B3D"/>
                 </a:solidFill>
@@ -14425,7 +14417,7 @@
               </a:defRPr>
             </a:pPr>
             <a:r>
-              <a:rPr sz="1125" b="1">
+              <a:rPr sz="1200" b="1">
                 <a:solidFill>
                   <a:srgbClr val="071B3D"/>
                 </a:solidFill>
@@ -14438,7 +14430,7 @@
           </a:p>
           <a:p>
             <a:pPr algn="l">
-              <a:defRPr sz="1125" b="1">
+              <a:defRPr sz="1200" b="1">
                 <a:solidFill>
                   <a:srgbClr val="071B3D"/>
                 </a:solidFill>
@@ -14448,7 +14440,7 @@
               </a:defRPr>
             </a:pPr>
             <a:r>
-              <a:rPr sz="1125" b="1">
+              <a:rPr sz="1200" b="1">
                 <a:solidFill>
                   <a:srgbClr val="071B3D"/>
                 </a:solidFill>
@@ -14542,7 +14534,7 @@
           <a:lstStyle/>
           <a:p>
             <a:pPr algn="l">
-              <a:defRPr sz="1125" b="1">
+              <a:defRPr sz="1200" b="1">
                 <a:solidFill>
                   <a:srgbClr val="071B3D"/>
                 </a:solidFill>
@@ -14552,7 +14544,7 @@
               </a:defRPr>
             </a:pPr>
             <a:r>
-              <a:rPr sz="1125" b="1">
+              <a:rPr sz="1200" b="1">
                 <a:solidFill>
                   <a:srgbClr val="071B3D"/>
                 </a:solidFill>
@@ -14565,7 +14557,7 @@
           </a:p>
           <a:p>
             <a:pPr algn="l">
-              <a:defRPr sz="1125" b="1">
+              <a:defRPr sz="1200" b="1">
                 <a:solidFill>
                   <a:srgbClr val="071B3D"/>
                 </a:solidFill>
@@ -14575,7 +14567,7 @@
               </a:defRPr>
             </a:pPr>
             <a:r>
-              <a:rPr sz="1125" b="1">
+              <a:rPr sz="1200" b="1">
                 <a:solidFill>
                   <a:srgbClr val="071B3D"/>
                 </a:solidFill>
@@ -14669,7 +14661,7 @@
           <a:lstStyle/>
           <a:p>
             <a:pPr algn="l">
-              <a:defRPr sz="1125" b="1">
+              <a:defRPr sz="1200" b="1">
                 <a:solidFill>
                   <a:srgbClr val="071B3D"/>
                 </a:solidFill>
@@ -14679,7 +14671,7 @@
               </a:defRPr>
             </a:pPr>
             <a:r>
-              <a:rPr sz="1125" b="1">
+              <a:rPr sz="1200" b="1">
                 <a:solidFill>
                   <a:srgbClr val="071B3D"/>
                 </a:solidFill>
@@ -14692,7 +14684,7 @@
           </a:p>
           <a:p>
             <a:pPr algn="l">
-              <a:defRPr sz="1125" b="1">
+              <a:defRPr sz="1200" b="1">
                 <a:solidFill>
                   <a:srgbClr val="071B3D"/>
                 </a:solidFill>
@@ -14702,7 +14694,7 @@
               </a:defRPr>
             </a:pPr>
             <a:r>
-              <a:rPr sz="1125" b="1">
+              <a:rPr sz="1200" b="1">
                 <a:solidFill>
                   <a:srgbClr val="071B3D"/>
                 </a:solidFill>
@@ -14796,7 +14788,7 @@
           <a:lstStyle/>
           <a:p>
             <a:pPr algn="l">
-              <a:defRPr sz="1125" b="1">
+              <a:defRPr sz="1200" b="1">
                 <a:solidFill>
                   <a:srgbClr val="071B3D"/>
                 </a:solidFill>
@@ -14806,7 +14798,7 @@
               </a:defRPr>
             </a:pPr>
             <a:r>
-              <a:rPr sz="1125" b="1">
+              <a:rPr sz="1200" b="1">
                 <a:solidFill>
                   <a:srgbClr val="071B3D"/>
                 </a:solidFill>
@@ -14819,7 +14811,7 @@
           </a:p>
           <a:p>
             <a:pPr algn="l">
-              <a:defRPr sz="1125" b="1">
+              <a:defRPr sz="1200" b="1">
                 <a:solidFill>
                   <a:srgbClr val="071B3D"/>
                 </a:solidFill>
@@ -14829,7 +14821,7 @@
               </a:defRPr>
             </a:pPr>
             <a:r>
-              <a:rPr sz="1125" b="1">
+              <a:rPr sz="1200" b="1">
                 <a:solidFill>
                   <a:srgbClr val="071B3D"/>
                 </a:solidFill>

</xml_diff>

<commit_message>
feat: polish Governance V3 executive messaging
- Replace short percentage-only facility observations with tier-based,
  implication-driven executive wording driven by compliance band.
- Make next-gate text action-oriented and derived from milestone/phase state.
- Improve Slide 3 matrix symbol readability: larger bold green checks and
  lighter bold gray dashes while keeping compact ✓/— form and 12pt minimum.
- Preserve template structure, slide count, masters, layouts, and coordinates.
- No change to approved 19/56 baseline, schema, migrations, or API contracts.
</commit_message>
<xml_diff>
--- a/src/modules/governance-v3/templates/Onboarding Status.pptx
+++ b/src/modules/governance-v3/templates/Onboarding Status.pptx
@@ -11601,13 +11601,10 @@
               </a:defRPr>
             </a:pPr>
             <a:r>
-              <a:rPr sz="1200" b="0" dirty="0">
-                <a:solidFill>
-                  <a:srgbClr val="66758A"/>
-                </a:solidFill>
-                <a:latin typeface="Calibri"/>
-                <a:ea typeface="Calibri"/>
-                <a:cs typeface="Calibri"/>
+              <a:rPr sz="1600" b="1">
+                <a:solidFill>
+                  <a:srgbClr val="169873"/>
+                </a:solidFill>
               </a:rPr>
               <a:t>✓ </a:t>
             </a:r>
@@ -11874,13 +11871,10 @@
                         <a:buNone/>
                       </a:pPr>
                       <a:r>
-                        <a:rPr sz="1200" b="1">
+                        <a:rPr sz="1400" b="1">
                           <a:solidFill>
-                            <a:srgbClr val="D93A45"/>
+                            <a:srgbClr val="A9A9A9"/>
                           </a:solidFill>
-                          <a:latin typeface="Calibri"/>
-                          <a:ea typeface="Calibri"/>
-                          <a:cs typeface="Calibri"/>
                         </a:rPr>
                         <a:t>—</a:t>
                       </a:r>
@@ -11901,13 +11895,10 @@
                         <a:buNone/>
                       </a:pPr>
                       <a:r>
-                        <a:rPr sz="1200" b="1" dirty="0">
+                        <a:rPr sz="1600" b="1">
                           <a:solidFill>
-                            <a:srgbClr val="00A878"/>
+                            <a:srgbClr val="169873"/>
                           </a:solidFill>
-                          <a:latin typeface="Calibri"/>
-                          <a:ea typeface="Calibri"/>
-                          <a:cs typeface="Calibri"/>
                         </a:rPr>
                         <a:t>✓ </a:t>
                       </a:r>
@@ -11947,13 +11938,10 @@
                         <a:buNone/>
                       </a:pPr>
                       <a:r>
-                        <a:rPr sz="1200" b="1">
+                        <a:rPr sz="1400" b="1">
                           <a:solidFill>
-                            <a:srgbClr val="D93A45"/>
+                            <a:srgbClr val="A9A9A9"/>
                           </a:solidFill>
-                          <a:latin typeface="Calibri"/>
-                          <a:ea typeface="Calibri"/>
-                          <a:cs typeface="Calibri"/>
                         </a:rPr>
                         <a:t>—</a:t>
                       </a:r>
@@ -11974,13 +11962,10 @@
                         <a:buNone/>
                       </a:pPr>
                       <a:r>
-                        <a:rPr sz="1200" b="1">
+                        <a:rPr sz="1400" b="1">
                           <a:solidFill>
-                            <a:srgbClr val="D93A45"/>
+                            <a:srgbClr val="A9A9A9"/>
                           </a:solidFill>
-                          <a:latin typeface="Calibri"/>
-                          <a:ea typeface="Calibri"/>
-                          <a:cs typeface="Calibri"/>
                         </a:rPr>
                         <a:t>—</a:t>
                       </a:r>
@@ -12035,13 +12020,10 @@
                         <a:buNone/>
                       </a:pPr>
                       <a:r>
-                        <a:rPr sz="1200" b="1">
+                        <a:rPr sz="1400" b="1">
                           <a:solidFill>
-                            <a:srgbClr val="D93A45"/>
+                            <a:srgbClr val="A9A9A9"/>
                           </a:solidFill>
-                          <a:latin typeface="Calibri"/>
-                          <a:ea typeface="Calibri"/>
-                          <a:cs typeface="Calibri"/>
                         </a:rPr>
                         <a:t>—</a:t>
                       </a:r>
@@ -12062,13 +12044,10 @@
                         <a:buNone/>
                       </a:pPr>
                       <a:r>
-                        <a:rPr lang="en-GB" sz="1200" b="1" dirty="0">
+                        <a:rPr lang="en-GB" sz="1600" b="1">
                           <a:solidFill>
-                            <a:srgbClr val="00A878"/>
+                            <a:srgbClr val="169873"/>
                           </a:solidFill>
-                          <a:latin typeface="+mn-lt"/>
-                          <a:ea typeface="+mn-ea"/>
-                          <a:cs typeface="+mn-cs"/>
                         </a:rPr>
                         <a:t>✓</a:t>
                       </a:r>
@@ -12089,13 +12068,10 @@
                         <a:buNone/>
                       </a:pPr>
                       <a:r>
-                        <a:rPr lang="en-GB" sz="1200" b="1" dirty="0">
+                        <a:rPr lang="en-GB" sz="1600" b="1">
                           <a:solidFill>
-                            <a:srgbClr val="00A878"/>
+                            <a:srgbClr val="169873"/>
                           </a:solidFill>
-                          <a:latin typeface="+mn-lt"/>
-                          <a:ea typeface="+mn-ea"/>
-                          <a:cs typeface="+mn-cs"/>
                         </a:rPr>
                         <a:t>✓</a:t>
                       </a:r>
@@ -12116,13 +12092,10 @@
                         <a:buNone/>
                       </a:pPr>
                       <a:r>
-                        <a:rPr sz="1200" b="1">
+                        <a:rPr sz="1400" b="1">
                           <a:solidFill>
-                            <a:srgbClr val="D93A45"/>
+                            <a:srgbClr val="A9A9A9"/>
                           </a:solidFill>
-                          <a:latin typeface="Calibri"/>
-                          <a:ea typeface="Calibri"/>
-                          <a:cs typeface="Calibri"/>
                         </a:rPr>
                         <a:t>—</a:t>
                       </a:r>
@@ -12177,13 +12150,10 @@
                         <a:buNone/>
                       </a:pPr>
                       <a:r>
-                        <a:rPr sz="1200" b="1">
+                        <a:rPr sz="1400" b="1">
                           <a:solidFill>
-                            <a:srgbClr val="D93A45"/>
+                            <a:srgbClr val="A9A9A9"/>
                           </a:solidFill>
-                          <a:latin typeface="Calibri"/>
-                          <a:ea typeface="Calibri"/>
-                          <a:cs typeface="Calibri"/>
                         </a:rPr>
                         <a:t>—</a:t>
                       </a:r>
@@ -12204,13 +12174,10 @@
                         <a:buNone/>
                       </a:pPr>
                       <a:r>
-                        <a:rPr lang="en-GB" sz="1200" b="1" dirty="0">
+                        <a:rPr lang="en-GB" sz="1600" b="1">
                           <a:solidFill>
-                            <a:srgbClr val="00A878"/>
+                            <a:srgbClr val="169873"/>
                           </a:solidFill>
-                          <a:latin typeface="+mn-lt"/>
-                          <a:ea typeface="+mn-ea"/>
-                          <a:cs typeface="+mn-cs"/>
                         </a:rPr>
                         <a:t>✓</a:t>
                       </a:r>
@@ -12231,13 +12198,10 @@
                         <a:buNone/>
                       </a:pPr>
                       <a:r>
-                        <a:rPr sz="1200" b="1">
+                        <a:rPr sz="1400" b="1">
                           <a:solidFill>
-                            <a:srgbClr val="D93A45"/>
+                            <a:srgbClr val="A9A9A9"/>
                           </a:solidFill>
-                          <a:latin typeface="Calibri"/>
-                          <a:ea typeface="Calibri"/>
-                          <a:cs typeface="Calibri"/>
                         </a:rPr>
                         <a:t>—</a:t>
                       </a:r>
@@ -12258,13 +12222,10 @@
                         <a:buNone/>
                       </a:pPr>
                       <a:r>
-                        <a:rPr sz="1200" b="1">
+                        <a:rPr sz="1400" b="1">
                           <a:solidFill>
-                            <a:srgbClr val="D93A45"/>
+                            <a:srgbClr val="A9A9A9"/>
                           </a:solidFill>
-                          <a:latin typeface="Calibri"/>
-                          <a:ea typeface="Calibri"/>
-                          <a:cs typeface="Calibri"/>
                         </a:rPr>
                         <a:t>—</a:t>
                       </a:r>
@@ -12319,13 +12280,10 @@
                         <a:buNone/>
                       </a:pPr>
                       <a:r>
-                        <a:rPr sz="1200" b="1">
+                        <a:rPr sz="1400" b="1">
                           <a:solidFill>
-                            <a:srgbClr val="D93A45"/>
+                            <a:srgbClr val="A9A9A9"/>
                           </a:solidFill>
-                          <a:latin typeface="Calibri"/>
-                          <a:ea typeface="Calibri"/>
-                          <a:cs typeface="Calibri"/>
                         </a:rPr>
                         <a:t>—</a:t>
                       </a:r>
@@ -12346,13 +12304,10 @@
                         <a:buNone/>
                       </a:pPr>
                       <a:r>
-                        <a:rPr lang="en-GB" sz="1200" b="1" dirty="0">
+                        <a:rPr lang="en-GB" sz="1600" b="1">
                           <a:solidFill>
-                            <a:srgbClr val="00A878"/>
+                            <a:srgbClr val="169873"/>
                           </a:solidFill>
-                          <a:latin typeface="+mn-lt"/>
-                          <a:ea typeface="+mn-ea"/>
-                          <a:cs typeface="+mn-cs"/>
                         </a:rPr>
                         <a:t>✓</a:t>
                       </a:r>
@@ -12373,13 +12328,10 @@
                         <a:buNone/>
                       </a:pPr>
                       <a:r>
-                        <a:rPr sz="1200" b="1">
+                        <a:rPr sz="1400" b="1">
                           <a:solidFill>
-                            <a:srgbClr val="D93A45"/>
+                            <a:srgbClr val="A9A9A9"/>
                           </a:solidFill>
-                          <a:latin typeface="Calibri"/>
-                          <a:ea typeface="Calibri"/>
-                          <a:cs typeface="Calibri"/>
                         </a:rPr>
                         <a:t>—</a:t>
                       </a:r>
@@ -12400,13 +12352,10 @@
                         <a:buNone/>
                       </a:pPr>
                       <a:r>
-                        <a:rPr sz="1200" b="1">
+                        <a:rPr sz="1400" b="1">
                           <a:solidFill>
-                            <a:srgbClr val="D93A45"/>
+                            <a:srgbClr val="A9A9A9"/>
                           </a:solidFill>
-                          <a:latin typeface="Calibri"/>
-                          <a:ea typeface="Calibri"/>
-                          <a:cs typeface="Calibri"/>
                         </a:rPr>
                         <a:t>—</a:t>
                       </a:r>
@@ -12461,13 +12410,10 @@
                         <a:buNone/>
                       </a:pPr>
                       <a:r>
-                        <a:rPr sz="1200" b="1">
+                        <a:rPr sz="1400" b="1">
                           <a:solidFill>
-                            <a:srgbClr val="D93A45"/>
+                            <a:srgbClr val="A9A9A9"/>
                           </a:solidFill>
-                          <a:latin typeface="Calibri"/>
-                          <a:ea typeface="Calibri"/>
-                          <a:cs typeface="Calibri"/>
                         </a:rPr>
                         <a:t>—</a:t>
                       </a:r>
@@ -12488,13 +12434,10 @@
                         <a:buNone/>
                       </a:pPr>
                       <a:r>
-                        <a:rPr lang="en-GB" sz="1200" b="1" dirty="0">
+                        <a:rPr lang="en-GB" sz="1600" b="1">
                           <a:solidFill>
-                            <a:srgbClr val="00A878"/>
+                            <a:srgbClr val="169873"/>
                           </a:solidFill>
-                          <a:latin typeface="+mn-lt"/>
-                          <a:ea typeface="+mn-ea"/>
-                          <a:cs typeface="+mn-cs"/>
                         </a:rPr>
                         <a:t>✓</a:t>
                       </a:r>
@@ -12515,13 +12458,10 @@
                         <a:buNone/>
                       </a:pPr>
                       <a:r>
-                        <a:rPr sz="1200" b="1" dirty="0">
+                        <a:rPr sz="1400" b="1">
                           <a:solidFill>
-                            <a:srgbClr val="D93A45"/>
+                            <a:srgbClr val="A9A9A9"/>
                           </a:solidFill>
-                          <a:latin typeface="Calibri"/>
-                          <a:ea typeface="Calibri"/>
-                          <a:cs typeface="Calibri"/>
                         </a:rPr>
                         <a:t>—</a:t>
                       </a:r>
@@ -12542,13 +12482,10 @@
                         <a:buNone/>
                       </a:pPr>
                       <a:r>
-                        <a:rPr sz="1200" b="1">
+                        <a:rPr sz="1400" b="1">
                           <a:solidFill>
-                            <a:srgbClr val="D93A45"/>
+                            <a:srgbClr val="A9A9A9"/>
                           </a:solidFill>
-                          <a:latin typeface="Calibri"/>
-                          <a:ea typeface="Calibri"/>
-                          <a:cs typeface="Calibri"/>
                         </a:rPr>
                         <a:t>—</a:t>
                       </a:r>
@@ -12603,13 +12540,10 @@
                         <a:buNone/>
                       </a:pPr>
                       <a:r>
-                        <a:rPr sz="1200" b="1">
+                        <a:rPr sz="1400" b="1">
                           <a:solidFill>
-                            <a:srgbClr val="D93A45"/>
+                            <a:srgbClr val="A9A9A9"/>
                           </a:solidFill>
-                          <a:latin typeface="Calibri"/>
-                          <a:ea typeface="Calibri"/>
-                          <a:cs typeface="Calibri"/>
                         </a:rPr>
                         <a:t>—</a:t>
                       </a:r>
@@ -12630,13 +12564,10 @@
                         <a:buNone/>
                       </a:pPr>
                       <a:r>
-                        <a:rPr lang="en-GB" sz="1200" b="1" dirty="0">
+                        <a:rPr lang="en-GB" sz="1600" b="1">
                           <a:solidFill>
-                            <a:srgbClr val="00A878"/>
+                            <a:srgbClr val="169873"/>
                           </a:solidFill>
-                          <a:latin typeface="+mn-lt"/>
-                          <a:ea typeface="+mn-ea"/>
-                          <a:cs typeface="+mn-cs"/>
                         </a:rPr>
                         <a:t>✓</a:t>
                       </a:r>
@@ -12657,13 +12588,10 @@
                         <a:buNone/>
                       </a:pPr>
                       <a:r>
-                        <a:rPr sz="1200" b="1" dirty="0">
+                        <a:rPr sz="1400" b="1">
                           <a:solidFill>
-                            <a:srgbClr val="D93A45"/>
+                            <a:srgbClr val="A9A9A9"/>
                           </a:solidFill>
-                          <a:latin typeface="Calibri"/>
-                          <a:ea typeface="Calibri"/>
-                          <a:cs typeface="Calibri"/>
                         </a:rPr>
                         <a:t>—</a:t>
                       </a:r>
@@ -12684,13 +12612,10 @@
                         <a:buNone/>
                       </a:pPr>
                       <a:r>
-                        <a:rPr sz="1200" b="1">
+                        <a:rPr sz="1400" b="1">
                           <a:solidFill>
-                            <a:srgbClr val="D93A45"/>
+                            <a:srgbClr val="A9A9A9"/>
                           </a:solidFill>
-                          <a:latin typeface="Calibri"/>
-                          <a:ea typeface="Calibri"/>
-                          <a:cs typeface="Calibri"/>
                         </a:rPr>
                         <a:t>—</a:t>
                       </a:r>
@@ -12745,13 +12670,10 @@
                         <a:buNone/>
                       </a:pPr>
                       <a:r>
-                        <a:rPr sz="1200" b="1" dirty="0">
+                        <a:rPr sz="1400" b="1">
                           <a:solidFill>
-                            <a:srgbClr val="D93A45"/>
+                            <a:srgbClr val="A9A9A9"/>
                           </a:solidFill>
-                          <a:latin typeface="Calibri"/>
-                          <a:ea typeface="Calibri"/>
-                          <a:cs typeface="Calibri"/>
                         </a:rPr>
                         <a:t>—</a:t>
                       </a:r>
@@ -12772,13 +12694,10 @@
                         <a:buNone/>
                       </a:pPr>
                       <a:r>
-                        <a:rPr lang="en-GB" sz="1200" b="1" dirty="0">
+                        <a:rPr lang="en-GB" sz="1600" b="1">
                           <a:solidFill>
-                            <a:srgbClr val="00A878"/>
+                            <a:srgbClr val="169873"/>
                           </a:solidFill>
-                          <a:latin typeface="+mn-lt"/>
-                          <a:ea typeface="+mn-ea"/>
-                          <a:cs typeface="+mn-cs"/>
                         </a:rPr>
                         <a:t>✓</a:t>
                       </a:r>
@@ -12799,13 +12718,10 @@
                         <a:buNone/>
                       </a:pPr>
                       <a:r>
-                        <a:rPr lang="en-GB" sz="1200" b="1" dirty="0">
+                        <a:rPr lang="en-GB" sz="1600" b="1">
                           <a:solidFill>
-                            <a:srgbClr val="00A878"/>
+                            <a:srgbClr val="169873"/>
                           </a:solidFill>
-                          <a:latin typeface="+mn-lt"/>
-                          <a:ea typeface="+mn-ea"/>
-                          <a:cs typeface="+mn-cs"/>
                         </a:rPr>
                         <a:t>✓</a:t>
                       </a:r>
@@ -12826,13 +12742,10 @@
                         <a:buNone/>
                       </a:pPr>
                       <a:r>
-                        <a:rPr sz="1200" b="1">
+                        <a:rPr sz="1400" b="1">
                           <a:solidFill>
-                            <a:srgbClr val="D93A45"/>
+                            <a:srgbClr val="A9A9A9"/>
                           </a:solidFill>
-                          <a:latin typeface="Calibri"/>
-                          <a:ea typeface="Calibri"/>
-                          <a:cs typeface="Calibri"/>
                         </a:rPr>
                         <a:t>—</a:t>
                       </a:r>
@@ -12887,13 +12800,10 @@
                         <a:buNone/>
                       </a:pPr>
                       <a:r>
-                        <a:rPr lang="en-GB" sz="1200" b="1" dirty="0">
+                        <a:rPr lang="en-GB" sz="1600" b="1">
                           <a:solidFill>
-                            <a:srgbClr val="00A878"/>
+                            <a:srgbClr val="169873"/>
                           </a:solidFill>
-                          <a:latin typeface="+mn-lt"/>
-                          <a:ea typeface="+mn-ea"/>
-                          <a:cs typeface="+mn-cs"/>
                         </a:rPr>
                         <a:t>✓</a:t>
                       </a:r>
@@ -12914,13 +12824,10 @@
                         <a:buNone/>
                       </a:pPr>
                       <a:r>
-                        <a:rPr lang="en-GB" sz="1200" b="1" dirty="0">
+                        <a:rPr lang="en-GB" sz="1600" b="1">
                           <a:solidFill>
-                            <a:srgbClr val="00A878"/>
+                            <a:srgbClr val="169873"/>
                           </a:solidFill>
-                          <a:latin typeface="+mn-lt"/>
-                          <a:ea typeface="+mn-ea"/>
-                          <a:cs typeface="+mn-cs"/>
                         </a:rPr>
                         <a:t>✓</a:t>
                       </a:r>
@@ -12941,13 +12848,10 @@
                         <a:buNone/>
                       </a:pPr>
                       <a:r>
-                        <a:rPr lang="en-GB" sz="1200" b="1" dirty="0">
+                        <a:rPr lang="en-GB" sz="1600" b="1">
                           <a:solidFill>
-                            <a:srgbClr val="00A878"/>
+                            <a:srgbClr val="169873"/>
                           </a:solidFill>
-                          <a:latin typeface="+mn-lt"/>
-                          <a:ea typeface="+mn-ea"/>
-                          <a:cs typeface="+mn-cs"/>
                         </a:rPr>
                         <a:t>✓</a:t>
                       </a:r>
@@ -12968,13 +12872,10 @@
                         <a:buNone/>
                       </a:pPr>
                       <a:r>
-                        <a:rPr lang="en-GB" sz="1200" b="1" dirty="0">
+                        <a:rPr lang="en-GB" sz="1600" b="1">
                           <a:solidFill>
-                            <a:srgbClr val="00A878"/>
+                            <a:srgbClr val="169873"/>
                           </a:solidFill>
-                          <a:latin typeface="+mn-lt"/>
-                          <a:ea typeface="+mn-ea"/>
-                          <a:cs typeface="+mn-cs"/>
                         </a:rPr>
                         <a:t>✓</a:t>
                       </a:r>
@@ -13029,13 +12930,10 @@
                         <a:buNone/>
                       </a:pPr>
                       <a:r>
-                        <a:rPr lang="en-GB" sz="1200" b="1" dirty="0">
+                        <a:rPr lang="en-GB" sz="1400" b="1">
                           <a:solidFill>
-                            <a:srgbClr val="D93A45"/>
+                            <a:srgbClr val="A9A9A9"/>
                           </a:solidFill>
-                          <a:latin typeface="+mn-lt"/>
-                          <a:ea typeface="+mn-ea"/>
-                          <a:cs typeface="+mn-cs"/>
                         </a:rPr>
                         <a:t>—</a:t>
                       </a:r>
@@ -13056,13 +12954,10 @@
                         <a:buNone/>
                       </a:pPr>
                       <a:r>
-                        <a:rPr lang="en-GB" sz="1200" b="1" dirty="0">
+                        <a:rPr lang="en-GB" sz="1400" b="1">
                           <a:solidFill>
-                            <a:srgbClr val="D93A45"/>
+                            <a:srgbClr val="A9A9A9"/>
                           </a:solidFill>
-                          <a:latin typeface="+mn-lt"/>
-                          <a:ea typeface="+mn-ea"/>
-                          <a:cs typeface="+mn-cs"/>
                         </a:rPr>
                         <a:t>—</a:t>
                       </a:r>
@@ -13083,13 +12978,10 @@
                         <a:buNone/>
                       </a:pPr>
                       <a:r>
-                        <a:rPr lang="en-GB" sz="1200" b="1" dirty="0">
+                        <a:rPr lang="en-GB" sz="1400" b="1">
                           <a:solidFill>
-                            <a:srgbClr val="D93A45"/>
+                            <a:srgbClr val="A9A9A9"/>
                           </a:solidFill>
-                          <a:latin typeface="+mn-lt"/>
-                          <a:ea typeface="+mn-ea"/>
-                          <a:cs typeface="+mn-cs"/>
                         </a:rPr>
                         <a:t>—</a:t>
                       </a:r>
@@ -13110,13 +13002,10 @@
                         <a:buNone/>
                       </a:pPr>
                       <a:r>
-                        <a:rPr sz="1200" b="1">
+                        <a:rPr sz="1400" b="1">
                           <a:solidFill>
-                            <a:srgbClr val="D93A45"/>
+                            <a:srgbClr val="A9A9A9"/>
                           </a:solidFill>
-                          <a:latin typeface="Calibri"/>
-                          <a:ea typeface="Calibri"/>
-                          <a:cs typeface="Calibri"/>
                         </a:rPr>
                         <a:t>—</a:t>
                       </a:r>
@@ -13171,13 +13060,10 @@
                         <a:buNone/>
                       </a:pPr>
                       <a:r>
-                        <a:rPr sz="1200" b="1" dirty="0">
+                        <a:rPr sz="1400" b="1">
                           <a:solidFill>
-                            <a:srgbClr val="D93A45"/>
+                            <a:srgbClr val="A9A9A9"/>
                           </a:solidFill>
-                          <a:latin typeface="Calibri"/>
-                          <a:ea typeface="Calibri"/>
-                          <a:cs typeface="Calibri"/>
                         </a:rPr>
                         <a:t>—</a:t>
                       </a:r>
@@ -13198,13 +13084,10 @@
                         <a:buNone/>
                       </a:pPr>
                       <a:r>
-                        <a:rPr lang="en-GB" sz="1200" b="1" dirty="0">
+                        <a:rPr lang="en-GB" sz="1600" b="1">
                           <a:solidFill>
-                            <a:srgbClr val="00A878"/>
+                            <a:srgbClr val="169873"/>
                           </a:solidFill>
-                          <a:latin typeface="+mn-lt"/>
-                          <a:ea typeface="+mn-ea"/>
-                          <a:cs typeface="+mn-cs"/>
                         </a:rPr>
                         <a:t>✓</a:t>
                       </a:r>
@@ -13225,13 +13108,10 @@
                         <a:buNone/>
                       </a:pPr>
                       <a:r>
-                        <a:rPr sz="1200" b="1" dirty="0">
+                        <a:rPr sz="1400" b="1">
                           <a:solidFill>
-                            <a:srgbClr val="D93A45"/>
+                            <a:srgbClr val="A9A9A9"/>
                           </a:solidFill>
-                          <a:latin typeface="Calibri"/>
-                          <a:ea typeface="Calibri"/>
-                          <a:cs typeface="Calibri"/>
                         </a:rPr>
                         <a:t>—</a:t>
                       </a:r>
@@ -13252,13 +13132,10 @@
                         <a:buNone/>
                       </a:pPr>
                       <a:r>
-                        <a:rPr sz="1200" b="1">
+                        <a:rPr sz="1400" b="1">
                           <a:solidFill>
-                            <a:srgbClr val="D93A45"/>
+                            <a:srgbClr val="A9A9A9"/>
                           </a:solidFill>
-                          <a:latin typeface="Calibri"/>
-                          <a:ea typeface="Calibri"/>
-                          <a:cs typeface="Calibri"/>
                         </a:rPr>
                         <a:t>—</a:t>
                       </a:r>
@@ -13313,13 +13190,10 @@
                         <a:buNone/>
                       </a:pPr>
                       <a:r>
-                        <a:rPr lang="en-GB" sz="1200" b="1" dirty="0">
+                        <a:rPr lang="en-GB" sz="1600" b="1">
                           <a:solidFill>
-                            <a:srgbClr val="00A878"/>
+                            <a:srgbClr val="169873"/>
                           </a:solidFill>
-                          <a:latin typeface="+mn-lt"/>
-                          <a:ea typeface="+mn-ea"/>
-                          <a:cs typeface="+mn-cs"/>
                         </a:rPr>
                         <a:t>✓</a:t>
                       </a:r>
@@ -13340,13 +13214,10 @@
                         <a:buNone/>
                       </a:pPr>
                       <a:r>
-                        <a:rPr lang="en-GB" sz="1200" b="1" dirty="0">
+                        <a:rPr lang="en-GB" sz="1600" b="1">
                           <a:solidFill>
-                            <a:srgbClr val="00A878"/>
+                            <a:srgbClr val="169873"/>
                           </a:solidFill>
-                          <a:latin typeface="+mn-lt"/>
-                          <a:ea typeface="+mn-ea"/>
-                          <a:cs typeface="+mn-cs"/>
                         </a:rPr>
                         <a:t>✓</a:t>
                       </a:r>
@@ -13367,13 +13238,10 @@
                         <a:buNone/>
                       </a:pPr>
                       <a:r>
-                        <a:rPr sz="1200" b="1">
+                        <a:rPr sz="1400" b="1">
                           <a:solidFill>
-                            <a:srgbClr val="D93A45"/>
+                            <a:srgbClr val="A9A9A9"/>
                           </a:solidFill>
-                          <a:latin typeface="Calibri"/>
-                          <a:ea typeface="Calibri"/>
-                          <a:cs typeface="Calibri"/>
                         </a:rPr>
                         <a:t>—</a:t>
                       </a:r>
@@ -13394,13 +13262,10 @@
                         <a:buNone/>
                       </a:pPr>
                       <a:r>
-                        <a:rPr sz="1200" b="1">
+                        <a:rPr sz="1400" b="1">
                           <a:solidFill>
-                            <a:srgbClr val="D93A45"/>
+                            <a:srgbClr val="A9A9A9"/>
                           </a:solidFill>
-                          <a:latin typeface="Calibri"/>
-                          <a:ea typeface="Calibri"/>
-                          <a:cs typeface="Calibri"/>
                         </a:rPr>
                         <a:t>—</a:t>
                       </a:r>
@@ -13455,13 +13320,10 @@
                         <a:buNone/>
                       </a:pPr>
                       <a:r>
-                        <a:rPr lang="en-GB" sz="1200" b="1" dirty="0">
+                        <a:rPr lang="en-GB" sz="1600" b="1">
                           <a:solidFill>
-                            <a:srgbClr val="00A878"/>
+                            <a:srgbClr val="169873"/>
                           </a:solidFill>
-                          <a:latin typeface="+mn-lt"/>
-                          <a:ea typeface="+mn-ea"/>
-                          <a:cs typeface="+mn-cs"/>
                         </a:rPr>
                         <a:t>✓</a:t>
                       </a:r>
@@ -13482,13 +13344,10 @@
                         <a:buNone/>
                       </a:pPr>
                       <a:r>
-                        <a:rPr lang="en-GB" sz="1200" b="1" dirty="0">
+                        <a:rPr lang="en-GB" sz="1600" b="1">
                           <a:solidFill>
-                            <a:srgbClr val="00A878"/>
+                            <a:srgbClr val="169873"/>
                           </a:solidFill>
-                          <a:latin typeface="+mn-lt"/>
-                          <a:ea typeface="+mn-ea"/>
-                          <a:cs typeface="+mn-cs"/>
                         </a:rPr>
                         <a:t>✓</a:t>
                       </a:r>
@@ -13509,13 +13368,10 @@
                         <a:buNone/>
                       </a:pPr>
                       <a:r>
-                        <a:rPr lang="en-GB" sz="1200" b="1" dirty="0">
+                        <a:rPr lang="en-GB" sz="1600" b="1">
                           <a:solidFill>
-                            <a:srgbClr val="00A878"/>
+                            <a:srgbClr val="169873"/>
                           </a:solidFill>
-                          <a:latin typeface="+mn-lt"/>
-                          <a:ea typeface="+mn-ea"/>
-                          <a:cs typeface="+mn-cs"/>
                         </a:rPr>
                         <a:t>✓</a:t>
                       </a:r>
@@ -13536,13 +13392,10 @@
                         <a:buNone/>
                       </a:pPr>
                       <a:r>
-                        <a:rPr sz="1200" b="1" dirty="0">
+                        <a:rPr sz="1400" b="1">
                           <a:solidFill>
-                            <a:srgbClr val="D93A45"/>
+                            <a:srgbClr val="A9A9A9"/>
                           </a:solidFill>
-                          <a:latin typeface="Calibri"/>
-                          <a:ea typeface="Calibri"/>
-                          <a:cs typeface="Calibri"/>
                         </a:rPr>
                         <a:t>—</a:t>
                       </a:r>
@@ -13597,13 +13450,10 @@
                         <a:buNone/>
                       </a:pPr>
                       <a:r>
-                        <a:rPr lang="en-GB" sz="1200" b="1" dirty="0">
+                        <a:rPr lang="en-GB" sz="1400" b="1">
                           <a:solidFill>
-                            <a:srgbClr val="D93A45"/>
+                            <a:srgbClr val="A9A9A9"/>
                           </a:solidFill>
-                          <a:latin typeface="+mn-lt"/>
-                          <a:ea typeface="+mn-ea"/>
-                          <a:cs typeface="+mn-cs"/>
                         </a:rPr>
                         <a:t>—</a:t>
                       </a:r>
@@ -13624,13 +13474,10 @@
                         <a:buNone/>
                       </a:pPr>
                       <a:r>
-                        <a:rPr sz="1200" b="1">
+                        <a:rPr sz="1400" b="1">
                           <a:solidFill>
-                            <a:srgbClr val="D93A45"/>
+                            <a:srgbClr val="A9A9A9"/>
                           </a:solidFill>
-                          <a:latin typeface="Calibri"/>
-                          <a:ea typeface="Calibri"/>
-                          <a:cs typeface="Calibri"/>
                         </a:rPr>
                         <a:t>—</a:t>
                       </a:r>
@@ -13651,13 +13498,10 @@
                         <a:buNone/>
                       </a:pPr>
                       <a:r>
-                        <a:rPr sz="1200" b="1">
+                        <a:rPr sz="1400" b="1">
                           <a:solidFill>
-                            <a:srgbClr val="D93A45"/>
+                            <a:srgbClr val="A9A9A9"/>
                           </a:solidFill>
-                          <a:latin typeface="Calibri"/>
-                          <a:ea typeface="Calibri"/>
-                          <a:cs typeface="Calibri"/>
                         </a:rPr>
                         <a:t>—</a:t>
                       </a:r>
@@ -13678,13 +13522,10 @@
                         <a:buNone/>
                       </a:pPr>
                       <a:r>
-                        <a:rPr sz="1200" b="1">
+                        <a:rPr sz="1400" b="1">
                           <a:solidFill>
-                            <a:srgbClr val="D93A45"/>
+                            <a:srgbClr val="A9A9A9"/>
                           </a:solidFill>
-                          <a:latin typeface="Calibri"/>
-                          <a:ea typeface="Calibri"/>
-                          <a:cs typeface="Calibri"/>
                         </a:rPr>
                         <a:t>—</a:t>
                       </a:r>
@@ -13739,13 +13580,10 @@
                         <a:buNone/>
                       </a:pPr>
                       <a:r>
-                        <a:rPr sz="1200" b="1">
+                        <a:rPr sz="1400" b="1">
                           <a:solidFill>
-                            <a:srgbClr val="D93A45"/>
+                            <a:srgbClr val="A9A9A9"/>
                           </a:solidFill>
-                          <a:latin typeface="Calibri"/>
-                          <a:ea typeface="Calibri"/>
-                          <a:cs typeface="Calibri"/>
                         </a:rPr>
                         <a:t>—</a:t>
                       </a:r>
@@ -13766,13 +13604,10 @@
                         <a:buNone/>
                       </a:pPr>
                       <a:r>
-                        <a:rPr sz="1200" b="1">
+                        <a:rPr sz="1400" b="1">
                           <a:solidFill>
-                            <a:srgbClr val="D93A45"/>
+                            <a:srgbClr val="A9A9A9"/>
                           </a:solidFill>
-                          <a:latin typeface="Calibri"/>
-                          <a:ea typeface="Calibri"/>
-                          <a:cs typeface="Calibri"/>
                         </a:rPr>
                         <a:t>—</a:t>
                       </a:r>
@@ -13793,13 +13628,10 @@
                         <a:buNone/>
                       </a:pPr>
                       <a:r>
-                        <a:rPr sz="1200" b="1">
+                        <a:rPr sz="1400" b="1">
                           <a:solidFill>
-                            <a:srgbClr val="D93A45"/>
+                            <a:srgbClr val="A9A9A9"/>
                           </a:solidFill>
-                          <a:latin typeface="Calibri"/>
-                          <a:ea typeface="Calibri"/>
-                          <a:cs typeface="Calibri"/>
                         </a:rPr>
                         <a:t>—</a:t>
                       </a:r>
@@ -13820,13 +13652,10 @@
                         <a:buNone/>
                       </a:pPr>
                       <a:r>
-                        <a:rPr sz="1200" b="1">
+                        <a:rPr sz="1400" b="1">
                           <a:solidFill>
-                            <a:srgbClr val="D93A45"/>
+                            <a:srgbClr val="A9A9A9"/>
                           </a:solidFill>
-                          <a:latin typeface="Calibri"/>
-                          <a:ea typeface="Calibri"/>
-                          <a:cs typeface="Calibri"/>
                         </a:rPr>
                         <a:t>—</a:t>
                       </a:r>

</xml_diff>